<commit_message>
Sharpen the Pages versus Cloudflare comparison
The slide framed the difference as "static pages only" against "handles
more than static", which does not tell a team which one their situation
needs. The decisive difference is whether there is anywhere to run code:
Pages serves files, so the publishable key is the only key available to
it, while Cloudflare Workers run server-side and are the only way a
secret key stays out of the shipped page.

Rewrites the third row on each side and the note accordingly, so the
choice connects to the two-keys and Secrets slides later in the section.

Claude-Session: https://claude.ai/code/session_01ThK5xFevzMSgSSoMhVCn6y
</commit_message>
<xml_diff>
--- a/examples/pptx/immersion-2-3-making-it-demoable.pptx
+++ b/examples/pptx/immersion-2-3-making-it-demoable.pptx
@@ -1682,7 +1682,7 @@
           <a:lstStyle/>
           <a:p>
             <a:r>
-              <a:t>Two ways to ship. GitHub Pages is already where your code is, a commit is a deploy, and it serves static pages only. Cloudflare handles more than static and is fast to set up, but it is another account to make.</a:t>
+              <a:t>Two ways to ship. GitHub Pages is already where your code is and a commit is a deploy, but it serves static files only, with nowhere to run code. Cloudflare is another account to make, and in exchange its Workers run code on a server, which is the only way a secret key stays out of the page.</a:t>
             </a:r>
           </a:p>
         </p:txBody>
@@ -25308,7 +25308,7 @@
                 </a:solidFill>
                 <a:latin typeface="Arial"/>
               </a:rPr>
-              <a:t>Handles more than static</a:t>
+              <a:t>Workers run your code</a:t>
             </a:r>
           </a:p>
         </p:txBody>
@@ -25357,7 +25357,7 @@
         <p:spPr>
           <a:xfrm>
             <a:off x="6233160" y="3517391"/>
-            <a:ext cx="5501640" cy="847344"/>
+            <a:ext cx="5958840" cy="847344"/>
           </a:xfrm>
           <a:prstGeom prst="rect">
             <a:avLst/>
@@ -25378,7 +25378,7 @@
                 </a:solidFill>
                 <a:latin typeface="Arial"/>
               </a:rPr>
-              <a:t>Fast to set up</a:t>
+              <a:t>Secret keys stay secret</a:t>
             </a:r>
           </a:p>
         </p:txBody>
@@ -25392,7 +25392,7 @@
         <p:spPr>
           <a:xfrm>
             <a:off x="457200" y="4639055"/>
-            <a:ext cx="5501640" cy="847344"/>
+            <a:ext cx="6582628" cy="847344"/>
           </a:xfrm>
           <a:prstGeom prst="rect">
             <a:avLst/>
@@ -25413,7 +25413,7 @@
                 </a:solidFill>
                 <a:latin typeface="Arial"/>
               </a:rPr>
-              <a:t>Static pages only</a:t>
+              <a:t>Static only, no server</a:t>
             </a:r>
           </a:p>
         </p:txBody>

</xml_diff>